<commit_message>
Evidencias: actualiza Word y presentación con la revisión de Roy y los PR #14 y #15
9 PR (5 con revisión registrada), AI Log con 24 registros, 5 respuestas incorrectas, 1 rechazo y
18 decisiones; QA de Einer en HU-01 y HU-04; revisión de Einer en HU-02 y HU-05; numeración y
referencias corregidas. PDF regenerado.

Co-Authored-By: Claude Sonnet 5.5 <noreply@anthropic.com>
</commit_message>
<xml_diff>
--- a/docs/Presentacion_Proyecto1.pptx
+++ b/docs/Presentacion_Proyecto1.pptx
@@ -1039,7 +1039,7 @@
           <a:p>
             <a:r>
               <a:rPr lang="en-US" dirty="0"/>
-              <a:t>Orden de la demo: calendario con días disponibles, ocupados y cerrados; reserva en un clic con los datos guardados; el enlace Gestionar mi cita para reprogramar y cancelar; y en el panel de administración la previsión y el botón Exportar CSV. Para la demo: cd backend, python seed.py --historico, python -m uvicorn app.main:app; y en otra terminal cd frontend, python -m http.server 5500; abrir index.html con ?api=http://localhost:8000.</a:t>
+              <a:t>Orden de la demo: calendario con días disponibles, ocupados y cerrados; reserva en un clic con los datos guardados; el enlace Gestionar mi cita para reprogramar y cancelar; y en el panel de administración la previsión y el botón Exportar CSV. Para la demo: cd backend, python seed.py --historico, python -m uvicorn app.main:app; y en otra terminal cd frontend, python -m http.server 5500; abrir index.html con ?api=http://localhost:8000. Token del panel admin: el ADMIN_TOKEN configurado (demo-token en la demo). El celular debe ser chileno, por ejemplo 9 4291 6570.</a:t>
             </a:r>
             <a:endParaRPr lang="en-US" dirty="0"/>
           </a:p>
@@ -2433,7 +2433,7 @@
                   <a:schemeClr val="bg1"/>
                 </a:solidFill>
               </a:rPr>
-              <a:t>Solo 3 de 7 PR tuvieron revisión formal</a:t>
+              <a:t>5 de 9 PR con revisión registrada</a:t>
             </a:r>
             <a:endParaRPr lang="en-US" sz="1600" dirty="0"/>
           </a:p>
@@ -2451,7 +2451,7 @@
                   <a:schemeClr val="bg1"/>
                 </a:solidFill>
               </a:rPr>
-              <a:t>Falta el QA registrado de HU-01 y HU-04</a:t>
+              <a:t>Parte de la revisión y el QA se hizo después del merge</a:t>
             </a:r>
             <a:endParaRPr lang="en-US" sz="1600" dirty="0"/>
           </a:p>
@@ -2784,7 +2784,7 @@
                   <a:schemeClr val="accent1"/>
                 </a:solidFill>
               </a:rPr>
-              <a:t>7</a:t>
+              <a:t>9</a:t>
             </a:r>
             <a:endParaRPr lang="en-US" sz="6600" dirty="0"/>
           </a:p>
@@ -7278,7 +7278,7 @@
                   <a:schemeClr val="tx1"/>
                 </a:solidFill>
               </a:rPr>
-              <a:t>Todo entra a main por Pull Request</a:t>
+              <a:t>Todo el código entra a main por Pull Request</a:t>
             </a:r>
             <a:endParaRPr lang="en-US" sz="1600" dirty="0"/>
           </a:p>
@@ -8296,7 +8296,7 @@
                   <a:schemeClr val="accent1"/>
                 </a:solidFill>
               </a:rPr>
-              <a:t>19</a:t>
+              <a:t>24</a:t>
             </a:r>
             <a:endParaRPr lang="en-US" sz="5400" dirty="0"/>
           </a:p>
@@ -8395,7 +8395,7 @@
                   <a:schemeClr val="accent1"/>
                 </a:solidFill>
               </a:rPr>
-              <a:t>4</a:t>
+              <a:t>5</a:t>
             </a:r>
             <a:endParaRPr lang="en-US" sz="5400" dirty="0"/>
           </a:p>
@@ -8593,7 +8593,7 @@
                   <a:schemeClr val="accent1"/>
                 </a:solidFill>
               </a:rPr>
-              <a:t>15</a:t>
+              <a:t>18</a:t>
             </a:r>
             <a:endParaRPr lang="en-US" sz="5400" dirty="0"/>
           </a:p>

</xml_diff>

<commit_message>
Evidencias: suma el PR #16 (10 PR) en Word y presentación
Co-Authored-By: Claude Sonnet 5.5 <noreply@anthropic.com>
</commit_message>
<xml_diff>
--- a/docs/Presentacion_Proyecto1.pptx
+++ b/docs/Presentacion_Proyecto1.pptx
@@ -2433,7 +2433,7 @@
                   <a:schemeClr val="bg1"/>
                 </a:solidFill>
               </a:rPr>
-              <a:t>5 de 9 PR con revisión registrada</a:t>
+              <a:t>5 de 10 PR con revisión registrada</a:t>
             </a:r>
             <a:endParaRPr lang="en-US" sz="1600" dirty="0"/>
           </a:p>
@@ -2784,7 +2784,7 @@
                   <a:schemeClr val="accent1"/>
                 </a:solidFill>
               </a:rPr>
-              <a:t>9</a:t>
+              <a:t>10</a:t>
             </a:r>
             <a:endParaRPr lang="en-US" sz="6600" dirty="0"/>
           </a:p>

</xml_diff>